<commit_message>
Logica de macrosecciones Controlada
</commit_message>
<xml_diff>
--- a/assets/templates/base_template.pptx
+++ b/assets/templates/base_template.pptx
@@ -139,7 +139,7 @@
             <a:spLocks noGrp="1"/>
           </p:cNvSpPr>
           <p:nvPr>
-            <p:ph type="subTitle" idx="1"/>
+            <p:ph type="subTitle" idx="1" hasCustomPrompt="1"/>
           </p:nvPr>
         </p:nvSpPr>
         <p:spPr>
@@ -197,8 +197,18 @@
           </a:lstStyle>
           <a:p>
             <a:r>
+              <a:rPr lang="es-ES" dirty="0"/>
+              <a:t>Haga clic para agregar su nombre completo</a:t>
+            </a:r>
+          </a:p>
+          <a:p>
+            <a:r>
+              <a:rPr lang="es-ES" dirty="0"/>
+              <a:t>Estudiante: </a:t>
+            </a:r>
+            <a:r>
               <a:rPr lang="es-ES"/>
-              <a:t>Haga clic para modificar el estilo de subtítulo del patrón</a:t>
+              <a:t>Nombre estudiante</a:t>
             </a:r>
             <a:endParaRPr lang="es-EC" dirty="0"/>
           </a:p>
@@ -564,7 +574,7 @@
             <a:fld id="{4D59AF61-A3AF-4FB1-8605-4E6750D58820}" type="datetimeFigureOut">
               <a:rPr lang="es-EC" smtClean="0"/>
               <a:pPr/>
-              <a:t>29/12/2025</a:t>
+              <a:t>11/1/2026</a:t>
             </a:fld>
             <a:endParaRPr lang="es-EC" dirty="0"/>
           </a:p>

</xml_diff>